<commit_message>
User manual screenshots recaptured from the current screens (in progress)
</commit_message>
<xml_diff>
--- a/docs/package/01_Sales/iNXT_BrokerVerse_Client_Presentation.pptx
+++ b/docs/package/01_Sales/iNXT_BrokerVerse_Client_Presentation.pptx
@@ -8516,8 +8516,8 @@
         </p:blipFill>
         <p:spPr>
           <a:xfrm>
-            <a:off x="6917602" y="1143000"/>
-            <a:ext cx="3751449" cy="2331720"/>
+            <a:off x="6914997" y="1143000"/>
+            <a:ext cx="3756660" cy="2331720"/>
           </a:xfrm>
           <a:prstGeom prst="rect">
             <a:avLst/>
@@ -8578,8 +8578,8 @@
         </p:blipFill>
         <p:spPr>
           <a:xfrm>
-            <a:off x="7082514" y="3840480"/>
-            <a:ext cx="3421625" cy="2194560"/>
+            <a:off x="6932443" y="3840480"/>
+            <a:ext cx="3721768" cy="2194560"/>
           </a:xfrm>
           <a:prstGeom prst="rect">
             <a:avLst/>
@@ -11084,8 +11084,8 @@
         </p:blipFill>
         <p:spPr>
           <a:xfrm>
-            <a:off x="6234156" y="1143000"/>
-            <a:ext cx="5115600" cy="2240280"/>
+            <a:off x="6015540" y="1143000"/>
+            <a:ext cx="5552830" cy="2240280"/>
           </a:xfrm>
           <a:prstGeom prst="rect">
             <a:avLst/>
@@ -11147,7 +11147,7 @@
         <p:spPr>
           <a:xfrm>
             <a:off x="5852160" y="3794760"/>
-            <a:ext cx="2880360" cy="1777877"/>
+            <a:ext cx="2880360" cy="1524604"/>
           </a:xfrm>
           <a:prstGeom prst="rect">
             <a:avLst/>
@@ -11167,7 +11167,7 @@
         </p:nvSpPr>
         <p:spPr>
           <a:xfrm>
-            <a:off x="5852160" y="5618357"/>
+            <a:off x="5852160" y="5365084"/>
             <a:ext cx="2880360" cy="228600"/>
           </a:xfrm>
           <a:prstGeom prst="rect">
@@ -11209,7 +11209,7 @@
         <p:spPr>
           <a:xfrm>
             <a:off x="8851392" y="3794760"/>
-            <a:ext cx="2880360" cy="1899547"/>
+            <a:ext cx="2880360" cy="1596613"/>
           </a:xfrm>
           <a:prstGeom prst="rect">
             <a:avLst/>
@@ -11229,7 +11229,7 @@
         </p:nvSpPr>
         <p:spPr>
           <a:xfrm>
-            <a:off x="8851392" y="5740027"/>
+            <a:off x="8851392" y="5437093"/>
             <a:ext cx="2880360" cy="228600"/>
           </a:xfrm>
           <a:prstGeom prst="rect">
@@ -12648,8 +12648,8 @@
         </p:blipFill>
         <p:spPr>
           <a:xfrm>
-            <a:off x="6802255" y="1234440"/>
-            <a:ext cx="4619481" cy="2377439"/>
+            <a:off x="6492240" y="1234440"/>
+            <a:ext cx="5239512" cy="2235826"/>
           </a:xfrm>
           <a:prstGeom prst="rect">
             <a:avLst/>
@@ -12669,7 +12669,7 @@
         </p:nvSpPr>
         <p:spPr>
           <a:xfrm>
-            <a:off x="6492240" y="3657599"/>
+            <a:off x="6492240" y="3515986"/>
             <a:ext cx="5239512" cy="228600"/>
           </a:xfrm>
           <a:prstGeom prst="rect">
@@ -12711,7 +12711,7 @@
         <p:spPr>
           <a:xfrm>
             <a:off x="6492240" y="4023360"/>
-            <a:ext cx="5239512" cy="1775110"/>
+            <a:ext cx="5239512" cy="1612504"/>
           </a:xfrm>
           <a:prstGeom prst="rect">
             <a:avLst/>
@@ -12731,7 +12731,7 @@
         </p:nvSpPr>
         <p:spPr>
           <a:xfrm>
-            <a:off x="6492240" y="5844190"/>
+            <a:off x="6492240" y="5681584"/>
             <a:ext cx="5239512" cy="228600"/>
           </a:xfrm>
           <a:prstGeom prst="rect">
@@ -51834,8 +51834,8 @@
         </p:blipFill>
         <p:spPr>
           <a:xfrm>
-            <a:off x="7055027" y="1143000"/>
-            <a:ext cx="3476600" cy="2331720"/>
+            <a:off x="7041517" y="1143000"/>
+            <a:ext cx="3503620" cy="2331720"/>
           </a:xfrm>
           <a:prstGeom prst="rect">
             <a:avLst/>
@@ -52873,8 +52873,8 @@
         </p:blipFill>
         <p:spPr>
           <a:xfrm>
-            <a:off x="7390106" y="1143000"/>
-            <a:ext cx="2806441" cy="2331720"/>
+            <a:off x="7373098" y="1143000"/>
+            <a:ext cx="2840458" cy="2331720"/>
           </a:xfrm>
           <a:prstGeom prst="rect">
             <a:avLst/>

</xml_diff>

<commit_message>
Hosting priced per environment set; environment model by broker size (in progress)
</commit_message>
<xml_diff>
--- a/docs/package/01_Sales/iNXT_BrokerVerse_Client_Presentation.pptx
+++ b/docs/package/01_Sales/iNXT_BrokerVerse_Client_Presentation.pptx
@@ -1899,12 +1899,27 @@
           </a:p>
           <a:p>
             <a:r>
-              <a:t>set-up support at day rates. The monthly prices are indicative estimates from public list prices and include production</a:t>
-            </a:r>
-          </a:p>
-          <a:p>
-            <a:r>
-              <a:t>and one UAT environment, daily backups, monitoring and patching; confirm with the provider before quoting.</a:t>
+              <a:t>set-up support at day rates. The monthly prices are indicative estimates from public list prices and cover the standing</a:t>
+            </a:r>
+          </a:p>
+          <a:p>
+            <a:r>
+              <a:t>environment set of the tier: Dev, UAT and Production for small and medium brokers; Dev, SIT, UAT and Production with high</a:t>
+            </a:r>
+          </a:p>
+          <a:p>
+            <a:r>
+              <a:t>availability for large brokers. A temporary Pre-Prod, restored from a production backup for the go-live rehearsal and</a:t>
+            </a:r>
+          </a:p>
+          <a:p>
+            <a:r>
+              <a:t>each major release, is billed per month of use. Daily backups, monitoring and patching are included; hosting fees do not</a:t>
+            </a:r>
+          </a:p>
+          <a:p>
+            <a:r>
+              <a:t>increase yearly. Confirm with the provider before quoting.</a:t>
             </a:r>
           </a:p>
         </p:txBody>
@@ -25481,7 +25496,7 @@
                 </a:solidFill>
                 <a:latin typeface="Calibri"/>
               </a:rPr>
-              <a:t>Indicative hosting price per month (optional, PHP, excl. VAT, estimates)</a:t>
+              <a:t>Indicative hosting per month, full environment set (optional, PHP, excl. VAT)</a:t>
             </a:r>
           </a:p>
         </p:txBody>
@@ -25735,7 +25750,7 @@
                           </a:solidFill>
                           <a:latin typeface="Calibri"/>
                         </a:rPr>
-                        <a:t>30,000.00</a:t>
+                        <a:t>43,000.00</a:t>
                       </a:r>
                     </a:p>
                   </a:txBody>
@@ -25777,7 +25792,7 @@
                           </a:solidFill>
                           <a:latin typeface="Calibri"/>
                         </a:rPr>
-                        <a:t>31,000.00</a:t>
+                        <a:t>46,000.00</a:t>
                       </a:r>
                     </a:p>
                   </a:txBody>
@@ -25819,7 +25834,7 @@
                           </a:solidFill>
                           <a:latin typeface="Calibri"/>
                         </a:rPr>
-                        <a:t>28,000.00</a:t>
+                        <a:t>42,000.00</a:t>
                       </a:r>
                     </a:p>
                   </a:txBody>
@@ -25905,7 +25920,7 @@
                           </a:solidFill>
                           <a:latin typeface="Calibri"/>
                         </a:rPr>
-                        <a:t>62,000.00</a:t>
+                        <a:t>69,000.00</a:t>
                       </a:r>
                     </a:p>
                   </a:txBody>
@@ -25947,7 +25962,7 @@
                           </a:solidFill>
                           <a:latin typeface="Calibri"/>
                         </a:rPr>
-                        <a:t>65,000.00</a:t>
+                        <a:t>73,000.00</a:t>
                       </a:r>
                     </a:p>
                   </a:txBody>
@@ -25989,7 +26004,7 @@
                           </a:solidFill>
                           <a:latin typeface="Calibri"/>
                         </a:rPr>
-                        <a:t>59,000.00</a:t>
+                        <a:t>67,000.00</a:t>
                       </a:r>
                     </a:p>
                   </a:txBody>
@@ -26075,7 +26090,7 @@
                           </a:solidFill>
                           <a:latin typeface="Calibri"/>
                         </a:rPr>
-                        <a:t>112,000.00</a:t>
+                        <a:t>143,000.00</a:t>
                       </a:r>
                     </a:p>
                   </a:txBody>
@@ -26117,7 +26132,7 @@
                           </a:solidFill>
                           <a:latin typeface="Calibri"/>
                         </a:rPr>
-                        <a:t>118,000.00</a:t>
+                        <a:t>150,000.00</a:t>
                       </a:r>
                     </a:p>
                   </a:txBody>
@@ -26159,7 +26174,7 @@
                           </a:solidFill>
                           <a:latin typeface="Calibri"/>
                         </a:rPr>
-                        <a:t>107,000.00</a:t>
+                        <a:t>135,000.00</a:t>
                       </a:r>
                     </a:p>
                   </a:txBody>
@@ -26245,7 +26260,7 @@
                           </a:solidFill>
                           <a:latin typeface="Calibri"/>
                         </a:rPr>
-                        <a:t>244,000.00</a:t>
+                        <a:t>256,000.00</a:t>
                       </a:r>
                     </a:p>
                   </a:txBody>
@@ -26287,7 +26302,7 @@
                           </a:solidFill>
                           <a:latin typeface="Calibri"/>
                         </a:rPr>
-                        <a:t>256,000.00</a:t>
+                        <a:t>269,000.00</a:t>
                       </a:r>
                     </a:p>
                   </a:txBody>
@@ -26329,7 +26344,7 @@
                           </a:solidFill>
                           <a:latin typeface="Calibri"/>
                         </a:rPr>
-                        <a:t>232,000.00</a:t>
+                        <a:t>242,000.00</a:t>
                       </a:r>
                     </a:p>
                   </a:txBody>
@@ -26401,7 +26416,7 @@
                 </a:solidFill>
                 <a:latin typeface="Calibri"/>
               </a:rPr>
-              <a:t>separate UAT and production environments, HTTPS, daily backups with point-in-time restore, monitoring, and production with two API instances and a standby database.</a:t>
+              <a:t>separate Dev, UAT and production environments (and SIT for large brokers), HTTPS, daily backups with point-in-time restore, monitoring, and production with two API instances and a standby database.</a:t>
             </a:r>
           </a:p>
         </p:txBody>
@@ -26434,7 +26449,7 @@
                 </a:solidFill>
                 <a:latin typeface="Calibri"/>
               </a:rPr>
-              <a:t>Production, one UAT environment, daily backups, monitoring, patching and certificates included. Self-hosting has no hosting fee.</a:t>
+              <a:t>Small and medium: Dev, UAT, Production. Large: Dev, SIT, UAT, Production. Temporary Pre-Prod billed per month of use. Self-hosting has no hosting fee.</a:t>
             </a:r>
           </a:p>
         </p:txBody>

</xml_diff>

<commit_message>
Fit assessment workbook, fit-gap register and sales materials rebuilt with the release verification figures
</commit_message>
<xml_diff>
--- a/docs/package/01_Sales/iNXT_BrokerVerse_Client_Presentation.pptx
+++ b/docs/package/01_Sales/iNXT_BrokerVerse_Client_Presentation.pptx
@@ -8699,8 +8699,8 @@
         </p:blipFill>
         <p:spPr>
           <a:xfrm>
-            <a:off x="6932443" y="3840480"/>
-            <a:ext cx="3721768" cy="2194560"/>
+            <a:off x="7129478" y="3840480"/>
+            <a:ext cx="3327698" cy="2194560"/>
           </a:xfrm>
           <a:prstGeom prst="rect">
             <a:avLst/>
@@ -12770,7 +12770,7 @@
         <p:spPr>
           <a:xfrm>
             <a:off x="6492240" y="1234440"/>
-            <a:ext cx="5239512" cy="2235826"/>
+            <a:ext cx="5239512" cy="1869963"/>
           </a:xfrm>
           <a:prstGeom prst="rect">
             <a:avLst/>
@@ -12790,7 +12790,7 @@
         </p:nvSpPr>
         <p:spPr>
           <a:xfrm>
-            <a:off x="6492240" y="3515986"/>
+            <a:off x="6492240" y="3150123"/>
             <a:ext cx="5239512" cy="228600"/>
           </a:xfrm>
           <a:prstGeom prst="rect">

</xml_diff>